<commit_message>
data-eng 덱 10개 재생성(pgsty/minio·kafka-get-offsets.sh) · 부록 PDF 갱신
Co-Authored-By: Claude Opus 5.5 <noreply@anthropic.com>
</commit_message>
<xml_diff>
--- a/data-eng/decks/w4d1s2.pptx
+++ b/data-eng/decks/w4d1s2.pptx
@@ -3100,7 +3100,7 @@
       <p:grpSpPr/>
       <p:sp>
         <p:nvSpPr>
-          <p:cNvPr id="2" name="Oval 1"/>
+          <p:cNvPr id="2" name="deckgen:decor"/>
           <p:cNvSpPr/>
           <p:nvPr/>
         </p:nvSpPr>
@@ -3130,7 +3130,7 @@
       </p:sp>
       <p:sp>
         <p:nvSpPr>
-          <p:cNvPr id="3" name="Oval 2"/>
+          <p:cNvPr id="3" name="deckgen:decor"/>
           <p:cNvSpPr/>
           <p:nvPr/>
         </p:nvSpPr>
@@ -3160,7 +3160,7 @@
       </p:sp>
       <p:sp>
         <p:nvSpPr>
-          <p:cNvPr id="4" name="Oval 3"/>
+          <p:cNvPr id="4" name="deckgen:decor"/>
           <p:cNvSpPr/>
           <p:nvPr/>
         </p:nvSpPr>
@@ -3190,7 +3190,7 @@
       </p:sp>
       <p:sp>
         <p:nvSpPr>
-          <p:cNvPr id="5" name="Rectangle 4"/>
+          <p:cNvPr id="5" name="deckgen:decor"/>
           <p:cNvSpPr/>
           <p:nvPr/>
         </p:nvSpPr>
@@ -3220,7 +3220,7 @@
       </p:sp>
       <p:sp>
         <p:nvSpPr>
-          <p:cNvPr id="6" name="Oval 5"/>
+          <p:cNvPr id="6" name="deckgen:decor"/>
           <p:cNvSpPr/>
           <p:nvPr/>
         </p:nvSpPr>
@@ -3250,7 +3250,7 @@
       </p:sp>
       <p:sp>
         <p:nvSpPr>
-          <p:cNvPr id="7" name="Oval 6"/>
+          <p:cNvPr id="7" name="deckgen:decor"/>
           <p:cNvSpPr/>
           <p:nvPr/>
         </p:nvSpPr>
@@ -3280,7 +3280,7 @@
       </p:sp>
       <p:sp>
         <p:nvSpPr>
-          <p:cNvPr id="8" name="Oval 7"/>
+          <p:cNvPr id="8" name="deckgen:decor"/>
           <p:cNvSpPr/>
           <p:nvPr/>
         </p:nvSpPr>
@@ -3310,7 +3310,7 @@
       </p:sp>
       <p:sp>
         <p:nvSpPr>
-          <p:cNvPr id="9" name="Oval 8"/>
+          <p:cNvPr id="9" name="deckgen:decor"/>
           <p:cNvSpPr/>
           <p:nvPr/>
         </p:nvSpPr>
@@ -3340,7 +3340,7 @@
       </p:sp>
       <p:sp>
         <p:nvSpPr>
-          <p:cNvPr id="10" name="Rectangle 9"/>
+          <p:cNvPr id="10" name="deckgen:decor"/>
           <p:cNvSpPr/>
           <p:nvPr/>
         </p:nvSpPr>
@@ -3600,7 +3600,7 @@
       <p:grpSpPr/>
       <p:sp>
         <p:nvSpPr>
-          <p:cNvPr id="2" name="Oval 1"/>
+          <p:cNvPr id="2" name="deckgen:decor"/>
           <p:cNvSpPr/>
           <p:nvPr/>
         </p:nvSpPr>
@@ -3630,7 +3630,7 @@
       </p:sp>
       <p:sp>
         <p:nvSpPr>
-          <p:cNvPr id="3" name="Oval 2"/>
+          <p:cNvPr id="3" name="deckgen:decor"/>
           <p:cNvSpPr/>
           <p:nvPr/>
         </p:nvSpPr>
@@ -3660,7 +3660,7 @@
       </p:sp>
       <p:sp>
         <p:nvSpPr>
-          <p:cNvPr id="4" name="Oval 3"/>
+          <p:cNvPr id="4" name="deckgen:decor"/>
           <p:cNvSpPr/>
           <p:nvPr/>
         </p:nvSpPr>
@@ -4737,7 +4737,7 @@
       <p:grpSpPr/>
       <p:sp>
         <p:nvSpPr>
-          <p:cNvPr id="2" name="Oval 1"/>
+          <p:cNvPr id="2" name="deckgen:decor"/>
           <p:cNvSpPr/>
           <p:nvPr/>
         </p:nvSpPr>
@@ -4767,7 +4767,7 @@
       </p:sp>
       <p:sp>
         <p:nvSpPr>
-          <p:cNvPr id="3" name="Oval 2"/>
+          <p:cNvPr id="3" name="deckgen:decor"/>
           <p:cNvSpPr/>
           <p:nvPr/>
         </p:nvSpPr>
@@ -5544,7 +5544,7 @@
       <p:grpSpPr/>
       <p:sp>
         <p:nvSpPr>
-          <p:cNvPr id="2" name="Oval 1"/>
+          <p:cNvPr id="2" name="deckgen:decor"/>
           <p:cNvSpPr/>
           <p:nvPr/>
         </p:nvSpPr>
@@ -5574,7 +5574,7 @@
       </p:sp>
       <p:sp>
         <p:nvSpPr>
-          <p:cNvPr id="3" name="Oval 2"/>
+          <p:cNvPr id="3" name="deckgen:decor"/>
           <p:cNvSpPr/>
           <p:nvPr/>
         </p:nvSpPr>
@@ -5604,7 +5604,7 @@
       </p:sp>
       <p:sp>
         <p:nvSpPr>
-          <p:cNvPr id="4" name="Oval 3"/>
+          <p:cNvPr id="4" name="deckgen:decor"/>
           <p:cNvSpPr/>
           <p:nvPr/>
         </p:nvSpPr>
@@ -6535,7 +6535,7 @@
       <p:grpSpPr/>
       <p:sp>
         <p:nvSpPr>
-          <p:cNvPr id="2" name="Oval 1"/>
+          <p:cNvPr id="2" name="deckgen:decor"/>
           <p:cNvSpPr/>
           <p:nvPr/>
         </p:nvSpPr>
@@ -6565,7 +6565,7 @@
       </p:sp>
       <p:sp>
         <p:nvSpPr>
-          <p:cNvPr id="3" name="Oval 2"/>
+          <p:cNvPr id="3" name="deckgen:decor"/>
           <p:cNvSpPr/>
           <p:nvPr/>
         </p:nvSpPr>
@@ -6595,7 +6595,7 @@
       </p:sp>
       <p:sp>
         <p:nvSpPr>
-          <p:cNvPr id="4" name="Oval 3"/>
+          <p:cNvPr id="4" name="deckgen:decor"/>
           <p:cNvSpPr/>
           <p:nvPr/>
         </p:nvSpPr>
@@ -7728,7 +7728,7 @@
       <p:grpSpPr/>
       <p:sp>
         <p:nvSpPr>
-          <p:cNvPr id="2" name="Oval 1"/>
+          <p:cNvPr id="2" name="deckgen:decor"/>
           <p:cNvSpPr/>
           <p:nvPr/>
         </p:nvSpPr>
@@ -7758,7 +7758,7 @@
       </p:sp>
       <p:sp>
         <p:nvSpPr>
-          <p:cNvPr id="3" name="Oval 2"/>
+          <p:cNvPr id="3" name="deckgen:decor"/>
           <p:cNvSpPr/>
           <p:nvPr/>
         </p:nvSpPr>
@@ -7788,7 +7788,7 @@
       </p:sp>
       <p:sp>
         <p:nvSpPr>
-          <p:cNvPr id="4" name="Oval 3"/>
+          <p:cNvPr id="4" name="deckgen:decor"/>
           <p:cNvSpPr/>
           <p:nvPr/>
         </p:nvSpPr>
@@ -8215,7 +8215,7 @@
                 <a:ea typeface="Pretendard"/>
                 <a:cs typeface="Pretendard"/>
               </a:rPr>
-              <a:t>minio/minio — 서버</a:t>
+              <a:t>pgsty/minio — 서버</a:t>
             </a:r>
           </a:p>
         </p:txBody>
@@ -8965,7 +8965,7 @@
                 <a:ea typeface="Pretendard"/>
                 <a:cs typeface="Pretendard"/>
               </a:rPr>
-              <a:t>minio/mc — 클라이언트</a:t>
+              <a:t>pgsty/mc — 클라이언트</a:t>
             </a:r>
           </a:p>
         </p:txBody>
@@ -9443,7 +9443,7 @@
       <p:grpSpPr/>
       <p:sp>
         <p:nvSpPr>
-          <p:cNvPr id="2" name="Oval 1"/>
+          <p:cNvPr id="2" name="deckgen:decor"/>
           <p:cNvSpPr/>
           <p:nvPr/>
         </p:nvSpPr>
@@ -9473,7 +9473,7 @@
       </p:sp>
       <p:sp>
         <p:nvSpPr>
-          <p:cNvPr id="3" name="Oval 2"/>
+          <p:cNvPr id="3" name="deckgen:decor"/>
           <p:cNvSpPr/>
           <p:nvPr/>
         </p:nvSpPr>
@@ -9503,7 +9503,7 @@
       </p:sp>
       <p:sp>
         <p:nvSpPr>
-          <p:cNvPr id="4" name="Oval 3"/>
+          <p:cNvPr id="4" name="deckgen:decor"/>
           <p:cNvSpPr/>
           <p:nvPr/>
         </p:nvSpPr>
@@ -10536,7 +10536,7 @@
       <p:grpSpPr/>
       <p:sp>
         <p:nvSpPr>
-          <p:cNvPr id="2" name="Oval 1"/>
+          <p:cNvPr id="2" name="deckgen:decor"/>
           <p:cNvSpPr/>
           <p:nvPr/>
         </p:nvSpPr>
@@ -10566,7 +10566,7 @@
       </p:sp>
       <p:sp>
         <p:nvSpPr>
-          <p:cNvPr id="3" name="Oval 2"/>
+          <p:cNvPr id="3" name="deckgen:decor"/>
           <p:cNvSpPr/>
           <p:nvPr/>
         </p:nvSpPr>
@@ -10596,7 +10596,7 @@
       </p:sp>
       <p:sp>
         <p:nvSpPr>
-          <p:cNvPr id="4" name="Oval 3"/>
+          <p:cNvPr id="4" name="deckgen:decor"/>
           <p:cNvSpPr/>
           <p:nvPr/>
         </p:nvSpPr>
@@ -11727,7 +11727,7 @@
       <p:grpSpPr/>
       <p:sp>
         <p:nvSpPr>
-          <p:cNvPr id="2" name="Oval 1"/>
+          <p:cNvPr id="2" name="deckgen:decor"/>
           <p:cNvSpPr/>
           <p:nvPr/>
         </p:nvSpPr>
@@ -11757,7 +11757,7 @@
       </p:sp>
       <p:sp>
         <p:nvSpPr>
-          <p:cNvPr id="3" name="Oval 2"/>
+          <p:cNvPr id="3" name="deckgen:decor"/>
           <p:cNvSpPr/>
           <p:nvPr/>
         </p:nvSpPr>
@@ -11787,7 +11787,7 @@
       </p:sp>
       <p:sp>
         <p:nvSpPr>
-          <p:cNvPr id="4" name="Oval 3"/>
+          <p:cNvPr id="4" name="deckgen:decor"/>
           <p:cNvSpPr/>
           <p:nvPr/>
         </p:nvSpPr>
@@ -12592,7 +12592,7 @@
       <p:grpSpPr/>
       <p:sp>
         <p:nvSpPr>
-          <p:cNvPr id="2" name="Oval 1"/>
+          <p:cNvPr id="2" name="deckgen:decor"/>
           <p:cNvSpPr/>
           <p:nvPr/>
         </p:nvSpPr>
@@ -12622,7 +12622,7 @@
       </p:sp>
       <p:sp>
         <p:nvSpPr>
-          <p:cNvPr id="3" name="Oval 2"/>
+          <p:cNvPr id="3" name="deckgen:decor"/>
           <p:cNvSpPr/>
           <p:nvPr/>
         </p:nvSpPr>
@@ -12652,7 +12652,7 @@
       </p:sp>
       <p:sp>
         <p:nvSpPr>
-          <p:cNvPr id="4" name="Oval 3"/>
+          <p:cNvPr id="4" name="deckgen:decor"/>
           <p:cNvSpPr/>
           <p:nvPr/>
         </p:nvSpPr>
@@ -14223,7 +14223,7 @@
       <p:grpSpPr/>
       <p:sp>
         <p:nvSpPr>
-          <p:cNvPr id="2" name="Oval 1"/>
+          <p:cNvPr id="2" name="deckgen:decor"/>
           <p:cNvSpPr/>
           <p:nvPr/>
         </p:nvSpPr>
@@ -14253,7 +14253,7 @@
       </p:sp>
       <p:sp>
         <p:nvSpPr>
-          <p:cNvPr id="3" name="Oval 2"/>
+          <p:cNvPr id="3" name="deckgen:decor"/>
           <p:cNvSpPr/>
           <p:nvPr/>
         </p:nvSpPr>
@@ -14283,7 +14283,7 @@
       </p:sp>
       <p:sp>
         <p:nvSpPr>
-          <p:cNvPr id="4" name="Oval 3"/>
+          <p:cNvPr id="4" name="deckgen:decor"/>
           <p:cNvSpPr/>
           <p:nvPr/>
         </p:nvSpPr>

</xml_diff>